<commit_message>
VERTEXA biznes planı: maliyyə modelləri, pitch deck-lər, komanda planı
- VERTEXA (FEEDRATE + QUOTEFLOW + FORMCHECK + CONFIGFLOW) 2-fazalı model
- Pitch deck (.pptx), 48 aylıq maliyyə modeli (.xlsx), şirkət planı (.docx)
- Lean 12+2 komanda, ~$1M seed, FAZA 2 öz gəliri ilə
- Pessimist/baza/optimist ssenarilər, supplier + escrow + ödəniş arxitekturası

Co-Authored-By: Claude Opus 4.8 <noreply@anthropic.com>
</commit_message>
<xml_diff>
--- a/FEEDRATE-Pitch-Deck-48ay.pptx
+++ b/FEEDRATE-Pitch-Deck-48ay.pptx
@@ -5323,7 +5323,7 @@
                 </a:solidFill>
                 <a:latin typeface="Calibri"/>
               </a:rPr>
-              <a:t>İlk 2 ay intensiv build — sonra güclü launch</a:t>
+              <a:t>İlk aydan işlək MVP və gəlir</a:t>
             </a:r>
           </a:p>
         </p:txBody>
@@ -5362,7 +5362,7 @@
                 </a:solidFill>
                 <a:latin typeface="Calibri"/>
               </a:rPr>
-              <a:t>Ay 1–2: İNTENSİV BUILD (gəlir yoxdur) — 18 nəfərlik komanda ilə Auth, DB, qiymət mühərriki, CAD, ödəniş, supplier-lər</a:t>
+              <a:t>Ay 1: İşlək MVP launch — ilk sifarişlər, gəlir başlayır ($10K/ay reklam, 18 nəfərlik komanda)</a:t>
             </a:r>
           </a:p>
           <a:p>
@@ -5378,7 +5378,7 @@
                 </a:solidFill>
                 <a:latin typeface="Calibri"/>
               </a:rPr>
-              <a:t>Ay 3: LAUNCH — güclü marketinq, ilk sifarişlər, supplier istehsalı, gəlir başlayır</a:t>
+              <a:t>Ay 1–3: Tam funksiyalar — escrow, supplier marşrutlaşdırma, cilalama (paralel, gəlir artır)</a:t>
             </a:r>
           </a:p>
           <a:p>
@@ -5956,7 +5956,7 @@
                 </a:solidFill>
                 <a:latin typeface="Calibri"/>
               </a:rPr>
-              <a:t>$31K</a:t>
+              <a:t>$39K</a:t>
             </a:r>
           </a:p>
           <a:p>
@@ -6031,7 +6031,7 @@
                 </a:solidFill>
                 <a:latin typeface="Calibri"/>
               </a:rPr>
-              <a:t>$215K</a:t>
+              <a:t>$265K</a:t>
             </a:r>
           </a:p>
           <a:p>
@@ -6106,7 +6106,7 @@
                 </a:solidFill>
                 <a:latin typeface="Calibri"/>
               </a:rPr>
-              <a:t>$756K</a:t>
+              <a:t>$932K</a:t>
             </a:r>
           </a:p>
           <a:p>
@@ -6181,7 +6181,7 @@
                 </a:solidFill>
                 <a:latin typeface="Calibri"/>
               </a:rPr>
-              <a:t>$369K</a:t>
+              <a:t>$463K</a:t>
             </a:r>
           </a:p>
           <a:p>
@@ -6256,7 +6256,7 @@
                 </a:solidFill>
                 <a:latin typeface="Calibri"/>
               </a:rPr>
-              <a:t>$2.58M</a:t>
+              <a:t>$3.18M</a:t>
             </a:r>
           </a:p>
           <a:p>
@@ -6331,7 +6331,7 @@
                 </a:solidFill>
                 <a:latin typeface="Calibri"/>
               </a:rPr>
-              <a:t>$9.07M</a:t>
+              <a:t>$11.19M</a:t>
             </a:r>
           </a:p>
           <a:p>
@@ -6386,7 +6386,7 @@
                 </a:solidFill>
                 <a:latin typeface="Calibri"/>
               </a:rPr>
-              <a:t>İl 1 $80K · İl 2 $418K · İl 3 $1.54M · İl 4 $5.44M gəlir   |   Breakeven ≈ 29-ci ay</a:t>
+              <a:t>İl 1 $116K · İl 2 $523K · İl 3 $1.90M · İl 4 $6.71M gəlir   |   Breakeven ≈ 28-ci ay</a:t>
             </a:r>
           </a:p>
           <a:p>
@@ -6402,7 +6402,7 @@
                 </a:solidFill>
                 <a:latin typeface="Calibri"/>
               </a:rPr>
-              <a:t>48 ayda sifariş 7,886/ay · ödənişli abunəçi 21,260 · komanda 24 nəfər · İl 4 NET $2.64M</a:t>
+              <a:t>48 ayda sifariş 9,717/ay · ödənişli abunəçi 26,200 · komanda 24 nəfər · İl 4 NET $3.42M</a:t>
             </a:r>
           </a:p>
         </p:txBody>
@@ -6586,7 +6586,7 @@
                 </a:solidFill>
                 <a:latin typeface="Calibri"/>
               </a:rPr>
-              <a:t>Tələb: $1.50M seed</a:t>
+              <a:t>Tələb: $1.60M seed</a:t>
             </a:r>
           </a:p>
         </p:txBody>
@@ -6645,7 +6645,7 @@
                 </a:solidFill>
                 <a:latin typeface="Calibri"/>
               </a:rPr>
-              <a:t>$1.50M</a:t>
+              <a:t>$1.60M</a:t>
             </a:r>
           </a:p>
           <a:p>
@@ -6795,7 +6795,7 @@
                 </a:solidFill>
                 <a:latin typeface="Calibri"/>
               </a:rPr>
-              <a:t>$9.07M</a:t>
+              <a:t>$11.19M</a:t>
             </a:r>
           </a:p>
           <a:p>
@@ -6866,7 +6866,7 @@
                 </a:solidFill>
                 <a:latin typeface="Calibri"/>
               </a:rPr>
-              <a:t>•  İlk 2 ay intensiv build (gəlirsiz) tam maliyyələşdirilir → ay 3-də güclü launch</a:t>
+              <a:t>•  İşlək MVP ilk aydan gəlir gətirir — komanda paralel tam məhsulu cilalayır</a:t>
             </a:r>
           </a:p>
           <a:p>
@@ -6882,7 +6882,7 @@
                 </a:solidFill>
                 <a:latin typeface="Calibri"/>
               </a:rPr>
-              <a:t>Plan: orta bazarı tut → $9.07M ARR-ə çat → yuxarı bazara genişlən, İl 4 NET $2.64M</a:t>
+              <a:t>Plan: orta bazarı tut → $11.19M ARR-ə çat → yuxarı bazara genişlən, İl 4 NET $3.42M</a:t>
             </a:r>
           </a:p>
         </p:txBody>

</xml_diff>